<commit_message>
Add team details (Team Twin, KIIT) to README and presentation
</commit_message>
<xml_diff>
--- a/docs/GlucoTwin_presentation.pptx
+++ b/docs/GlucoTwin_presentation.pptx
@@ -3261,7 +3261,7 @@
               </a:defRPr>
             </a:pPr>
             <a:r>
-              <a:t>&lt;Team Name&gt;  ·  &lt;College / Incubator&gt;</a:t>
+              <a:t>Team Twin  ·  KIIT, Bhubaneswar</a:t>
             </a:r>
           </a:p>
           <a:p>
@@ -3455,7 +3455,7 @@
               </a:defRPr>
             </a:pPr>
             <a:r>
-              <a:t>GlucoTwin · &lt;Team Name&gt; · Digital Twin Challenge 2026</a:t>
+              <a:t>GlucoTwin · Team Twin · Digital Twin Challenge 2026</a:t>
             </a:r>
           </a:p>
         </p:txBody>
@@ -3681,7 +3681,7 @@
               </a:defRPr>
             </a:pPr>
             <a:r>
-              <a:t>GlucoTwin · &lt;Team Name&gt; · Digital Twin Challenge 2026</a:t>
+              <a:t>GlucoTwin · Team Twin · Digital Twin Challenge 2026</a:t>
             </a:r>
           </a:p>
         </p:txBody>
@@ -3922,7 +3922,7 @@
               </a:defRPr>
             </a:pPr>
             <a:r>
-              <a:t>GlucoTwin · &lt;Team Name&gt; · Digital Twin Challenge 2026</a:t>
+              <a:t>GlucoTwin · Team Twin · Digital Twin Challenge 2026</a:t>
             </a:r>
           </a:p>
         </p:txBody>
@@ -4256,7 +4256,7 @@
               </a:defRPr>
             </a:pPr>
             <a:r>
-              <a:t>GlucoTwin · &lt;Team Name&gt; · Digital Twin Challenge 2026</a:t>
+              <a:t>GlucoTwin · Team Twin · Digital Twin Challenge 2026</a:t>
             </a:r>
           </a:p>
         </p:txBody>
@@ -4521,7 +4521,7 @@
               </a:defRPr>
             </a:pPr>
             <a:r>
-              <a:t>GlucoTwin · &lt;Team Name&gt; · Digital Twin Challenge 2026</a:t>
+              <a:t>GlucoTwin · Team Twin · Digital Twin Challenge 2026</a:t>
             </a:r>
           </a:p>
         </p:txBody>
@@ -4723,7 +4723,7 @@
               </a:defRPr>
             </a:pPr>
             <a:r>
-              <a:t>GlucoTwin · &lt;Team Name&gt; · Digital Twin Challenge 2026</a:t>
+              <a:t>GlucoTwin · Team Twin · Digital Twin Challenge 2026</a:t>
             </a:r>
           </a:p>
         </p:txBody>
@@ -5073,7 +5073,7 @@
               </a:defRPr>
             </a:pPr>
             <a:r>
-              <a:t>GlucoTwin · &lt;Team Name&gt; · Digital Twin Challenge 2026</a:t>
+              <a:t>GlucoTwin · Team Twin · Digital Twin Challenge 2026</a:t>
             </a:r>
           </a:p>
         </p:txBody>
@@ -5391,7 +5391,7 @@
               </a:defRPr>
             </a:pPr>
             <a:r>
-              <a:t>GlucoTwin · &lt;Team Name&gt; · Digital Twin Challenge 2026</a:t>
+              <a:t>GlucoTwin · Team Twin · Digital Twin Challenge 2026</a:t>
             </a:r>
           </a:p>
         </p:txBody>
@@ -5820,7 +5820,7 @@
               </a:defRPr>
             </a:pPr>
             <a:r>
-              <a:t>GlucoTwin · &lt;Team Name&gt; · Digital Twin Challenge 2026</a:t>
+              <a:t>GlucoTwin · Team Twin · Digital Twin Challenge 2026</a:t>
             </a:r>
           </a:p>
         </p:txBody>
@@ -6197,7 +6197,7 @@
               </a:defRPr>
             </a:pPr>
             <a:r>
-              <a:t>&lt;Team Name&gt; · &lt;College / Incubator&gt; · github.com/&lt;your-org&gt;/&lt;repo&gt;</a:t>
+              <a:t>Team Twin · KIIT, Bhubaneswar · github.com/maxlovesher/twin_KIIT</a:t>
             </a:r>
           </a:p>
         </p:txBody>
@@ -6375,7 +6375,7 @@
               </a:defRPr>
             </a:pPr>
             <a:r>
-              <a:t>GlucoTwin · &lt;Team Name&gt; · Digital Twin Challenge 2026</a:t>
+              <a:t>GlucoTwin · Team Twin · Digital Twin Challenge 2026</a:t>
             </a:r>
           </a:p>
         </p:txBody>
@@ -6754,7 +6754,7 @@
               </a:defRPr>
             </a:pPr>
             <a:r>
-              <a:t>GlucoTwin · &lt;Team Name&gt; · Digital Twin Challenge 2026</a:t>
+              <a:t>GlucoTwin · Team Twin · Digital Twin Challenge 2026</a:t>
             </a:r>
           </a:p>
         </p:txBody>
@@ -6956,7 +6956,7 @@
               </a:defRPr>
             </a:pPr>
             <a:r>
-              <a:t>GlucoTwin · &lt;Team Name&gt; · Digital Twin Challenge 2026</a:t>
+              <a:t>GlucoTwin · Team Twin · Digital Twin Challenge 2026</a:t>
             </a:r>
           </a:p>
         </p:txBody>
@@ -7293,7 +7293,7 @@
               </a:defRPr>
             </a:pPr>
             <a:r>
-              <a:t>GlucoTwin · &lt;Team Name&gt; · Digital Twin Challenge 2026</a:t>
+              <a:t>GlucoTwin · Team Twin · Digital Twin Challenge 2026</a:t>
             </a:r>
           </a:p>
         </p:txBody>
@@ -7550,7 +7550,7 @@
               </a:defRPr>
             </a:pPr>
             <a:r>
-              <a:t>GlucoTwin · &lt;Team Name&gt; · Digital Twin Challenge 2026</a:t>
+              <a:t>GlucoTwin · Team Twin · Digital Twin Challenge 2026</a:t>
             </a:r>
           </a:p>
         </p:txBody>
@@ -8080,7 +8080,7 @@
               </a:defRPr>
             </a:pPr>
             <a:r>
-              <a:t>GlucoTwin · &lt;Team Name&gt; · Digital Twin Challenge 2026</a:t>
+              <a:t>GlucoTwin · Team Twin · Digital Twin Challenge 2026</a:t>
             </a:r>
           </a:p>
         </p:txBody>
@@ -8337,7 +8337,7 @@
               </a:defRPr>
             </a:pPr>
             <a:r>
-              <a:t>GlucoTwin · &lt;Team Name&gt; · Digital Twin Challenge 2026</a:t>
+              <a:t>GlucoTwin · Team Twin · Digital Twin Challenge 2026</a:t>
             </a:r>
           </a:p>
         </p:txBody>
@@ -8594,7 +8594,7 @@
               </a:defRPr>
             </a:pPr>
             <a:r>
-              <a:t>GlucoTwin · &lt;Team Name&gt; · Digital Twin Challenge 2026</a:t>
+              <a:t>GlucoTwin · Team Twin · Digital Twin Challenge 2026</a:t>
             </a:r>
           </a:p>
         </p:txBody>

</xml_diff>

<commit_message>
Add one-click start.bat / start.sh launchers; pin scikit-learn and retrain models
The saved model pickles failed to load on a fresh install (No module named '_loss')
because they were trained with a different scikit-learn than pip now installs.
Pin scikit-learn==1.7.2, retrain the bundles in a clean venv, and add the
Excel readers (openpyxl, xlrd) the real-data loader needs. start.bat/start.sh
create a private .venv, install requirements on first run and open the dashboard.
</commit_message>
<xml_diff>
--- a/docs/GlucoTwin_presentation.pptx
+++ b/docs/GlucoTwin_presentation.pptx
@@ -3477,7 +3477,7 @@
         <p:spPr>
           <a:xfrm>
             <a:off x="457200" y="1463040"/>
-            <a:ext cx="6949440" cy="3106104"/>
+            <a:ext cx="6949440" cy="3109846"/>
           </a:xfrm>
           <a:prstGeom prst="rect">
             <a:avLst/>
@@ -3501,7 +3501,7 @@
         <p:spPr>
           <a:xfrm>
             <a:off x="7589520" y="1737360"/>
-            <a:ext cx="4206240" cy="2485123"/>
+            <a:ext cx="4206240" cy="2497717"/>
           </a:xfrm>
           <a:prstGeom prst="rect">
             <a:avLst/>
@@ -3742,7 +3742,7 @@
         <p:spPr>
           <a:xfrm>
             <a:off x="822960" y="2194560"/>
-            <a:ext cx="10515600" cy="3913653"/>
+            <a:ext cx="10515600" cy="3930072"/>
           </a:xfrm>
           <a:prstGeom prst="rect">
             <a:avLst/>
@@ -3943,8 +3943,8 @@
         </p:blipFill>
         <p:spPr>
           <a:xfrm>
-            <a:off x="548639" y="1463040"/>
-            <a:ext cx="5669280" cy="3261920"/>
+            <a:off x="548640" y="1463040"/>
+            <a:ext cx="5669280" cy="3271538"/>
           </a:xfrm>
           <a:prstGeom prst="rect">
             <a:avLst/>
@@ -7113,7 +7113,7 @@
         <p:spPr>
           <a:xfrm>
             <a:off x="5669280" y="1645920"/>
-            <a:ext cx="6126480" cy="2280128"/>
+            <a:ext cx="6126480" cy="2289694"/>
           </a:xfrm>
           <a:prstGeom prst="rect">
             <a:avLst/>
@@ -7369,8 +7369,8 @@
         </p:blipFill>
         <p:spPr>
           <a:xfrm>
-            <a:off x="885912" y="2971800"/>
-            <a:ext cx="10389695" cy="3291839"/>
+            <a:off x="912237" y="2971800"/>
+            <a:ext cx="10337044" cy="3291839"/>
           </a:xfrm>
           <a:prstGeom prst="rect">
             <a:avLst/>
@@ -7899,8 +7899,8 @@
         </p:blipFill>
         <p:spPr>
           <a:xfrm>
-            <a:off x="1012985" y="3291840"/>
-            <a:ext cx="10135548" cy="2971799"/>
+            <a:off x="997782" y="3291840"/>
+            <a:ext cx="10165955" cy="2971799"/>
           </a:xfrm>
           <a:prstGeom prst="rect">
             <a:avLst/>
@@ -8157,7 +8157,7 @@
         <p:spPr>
           <a:xfrm>
             <a:off x="548640" y="2743200"/>
-            <a:ext cx="11064240" cy="3512978"/>
+            <a:ext cx="11064240" cy="3520191"/>
           </a:xfrm>
           <a:prstGeom prst="rect">
             <a:avLst/>
@@ -8671,7 +8671,7 @@
         <p:spPr>
           <a:xfrm>
             <a:off x="548640" y="2743200"/>
-            <a:ext cx="11064240" cy="3374908"/>
+            <a:ext cx="11064240" cy="3369872"/>
           </a:xfrm>
           <a:prstGeom prst="rect">
             <a:avLst/>

</xml_diff>

<commit_message>
Add live demo link (glucotwin-kiit.streamlit.app) to README and closing slide
</commit_message>
<xml_diff>
--- a/docs/GlucoTwin_presentation.pptx
+++ b/docs/GlucoTwin_presentation.pptx
@@ -6198,6 +6198,45 @@
             </a:pPr>
             <a:r>
               <a:t>Team Twin · KIIT, Bhubaneswar · github.com/maxlovesher/twin_KIIT</a:t>
+            </a:r>
+          </a:p>
+        </p:txBody>
+      </p:sp>
+      <p:sp>
+        <p:nvSpPr>
+          <p:cNvPr id="5" name="TextBox 4"/>
+          <p:cNvSpPr txBox="1"/>
+          <p:nvPr/>
+        </p:nvSpPr>
+        <p:spPr>
+          <a:xfrm>
+            <a:off x="731520" y="4023360"/>
+            <a:ext cx="10515600" cy="914400"/>
+          </a:xfrm>
+          <a:prstGeom prst="rect">
+            <a:avLst/>
+          </a:prstGeom>
+          <a:noFill/>
+        </p:spPr>
+        <p:txBody>
+          <a:bodyPr wrap="square">
+            <a:spAutoFit/>
+          </a:bodyPr>
+          <a:lstStyle/>
+          <a:p>
+            <a:pPr>
+              <a:spcAft>
+                <a:spcPts val="600"/>
+              </a:spcAft>
+              <a:defRPr sz="1800" b="1">
+                <a:solidFill>
+                  <a:srgbClr val="FFFFFF"/>
+                </a:solidFill>
+                <a:latin typeface="Segoe UI"/>
+              </a:defRPr>
+            </a:pPr>
+            <a:r>
+              <a:t>Live demo: glucotwin-kiit.streamlit.app</a:t>
             </a:r>
           </a:p>
         </p:txBody>

</xml_diff>